<commit_message>
new updates on dashboard design
</commit_message>
<xml_diff>
--- a/Bank+Customer+Churn Project -Online(Excel)/Desciprtion.pptx
+++ b/Bank+Customer+Churn Project -Online(Excel)/Desciprtion.pptx
@@ -259,7 +259,7 @@
           <a:p>
             <a:fld id="{C9FDA5CA-BA5C-4445-939A-5B3E61C0C0E1}" type="datetimeFigureOut">
               <a:rPr lang="en-US" smtClean="0"/>
-              <a:t>7/26/2025</a:t>
+              <a:t>4/3/2026</a:t>
             </a:fld>
             <a:endParaRPr lang="en-US"/>
           </a:p>
@@ -457,7 +457,7 @@
           <a:p>
             <a:fld id="{C9FDA5CA-BA5C-4445-939A-5B3E61C0C0E1}" type="datetimeFigureOut">
               <a:rPr lang="en-US" smtClean="0"/>
-              <a:t>7/26/2025</a:t>
+              <a:t>4/3/2026</a:t>
             </a:fld>
             <a:endParaRPr lang="en-US"/>
           </a:p>
@@ -665,7 +665,7 @@
           <a:p>
             <a:fld id="{C9FDA5CA-BA5C-4445-939A-5B3E61C0C0E1}" type="datetimeFigureOut">
               <a:rPr lang="en-US" smtClean="0"/>
-              <a:t>7/26/2025</a:t>
+              <a:t>4/3/2026</a:t>
             </a:fld>
             <a:endParaRPr lang="en-US"/>
           </a:p>
@@ -863,7 +863,7 @@
           <a:p>
             <a:fld id="{C9FDA5CA-BA5C-4445-939A-5B3E61C0C0E1}" type="datetimeFigureOut">
               <a:rPr lang="en-US" smtClean="0"/>
-              <a:t>7/26/2025</a:t>
+              <a:t>4/3/2026</a:t>
             </a:fld>
             <a:endParaRPr lang="en-US"/>
           </a:p>
@@ -1138,7 +1138,7 @@
           <a:p>
             <a:fld id="{C9FDA5CA-BA5C-4445-939A-5B3E61C0C0E1}" type="datetimeFigureOut">
               <a:rPr lang="en-US" smtClean="0"/>
-              <a:t>7/26/2025</a:t>
+              <a:t>4/3/2026</a:t>
             </a:fld>
             <a:endParaRPr lang="en-US"/>
           </a:p>
@@ -1403,7 +1403,7 @@
           <a:p>
             <a:fld id="{C9FDA5CA-BA5C-4445-939A-5B3E61C0C0E1}" type="datetimeFigureOut">
               <a:rPr lang="en-US" smtClean="0"/>
-              <a:t>7/26/2025</a:t>
+              <a:t>4/3/2026</a:t>
             </a:fld>
             <a:endParaRPr lang="en-US"/>
           </a:p>
@@ -1815,7 +1815,7 @@
           <a:p>
             <a:fld id="{C9FDA5CA-BA5C-4445-939A-5B3E61C0C0E1}" type="datetimeFigureOut">
               <a:rPr lang="en-US" smtClean="0"/>
-              <a:t>7/26/2025</a:t>
+              <a:t>4/3/2026</a:t>
             </a:fld>
             <a:endParaRPr lang="en-US"/>
           </a:p>
@@ -1956,7 +1956,7 @@
           <a:p>
             <a:fld id="{C9FDA5CA-BA5C-4445-939A-5B3E61C0C0E1}" type="datetimeFigureOut">
               <a:rPr lang="en-US" smtClean="0"/>
-              <a:t>7/26/2025</a:t>
+              <a:t>4/3/2026</a:t>
             </a:fld>
             <a:endParaRPr lang="en-US"/>
           </a:p>
@@ -2069,7 +2069,7 @@
           <a:p>
             <a:fld id="{C9FDA5CA-BA5C-4445-939A-5B3E61C0C0E1}" type="datetimeFigureOut">
               <a:rPr lang="en-US" smtClean="0"/>
-              <a:t>7/26/2025</a:t>
+              <a:t>4/3/2026</a:t>
             </a:fld>
             <a:endParaRPr lang="en-US"/>
           </a:p>
@@ -2380,7 +2380,7 @@
           <a:p>
             <a:fld id="{C9FDA5CA-BA5C-4445-939A-5B3E61C0C0E1}" type="datetimeFigureOut">
               <a:rPr lang="en-US" smtClean="0"/>
-              <a:t>7/26/2025</a:t>
+              <a:t>4/3/2026</a:t>
             </a:fld>
             <a:endParaRPr lang="en-US"/>
           </a:p>
@@ -2668,7 +2668,7 @@
           <a:p>
             <a:fld id="{C9FDA5CA-BA5C-4445-939A-5B3E61C0C0E1}" type="datetimeFigureOut">
               <a:rPr lang="en-US" smtClean="0"/>
-              <a:t>7/26/2025</a:t>
+              <a:t>4/3/2026</a:t>
             </a:fld>
             <a:endParaRPr lang="en-US"/>
           </a:p>
@@ -2909,7 +2909,7 @@
           <a:p>
             <a:fld id="{C9FDA5CA-BA5C-4445-939A-5B3E61C0C0E1}" type="datetimeFigureOut">
               <a:rPr lang="en-US" smtClean="0"/>
-              <a:t>7/26/2025</a:t>
+              <a:t>4/3/2026</a:t>
             </a:fld>
             <a:endParaRPr lang="en-US"/>
           </a:p>
@@ -3341,14 +3341,14 @@
           <p:nvPr>
             <p:extLst>
               <p:ext uri="{D42A27DB-BD31-4B8C-83A1-F6EECF244321}">
-                <p14:modId xmlns:p14="http://schemas.microsoft.com/office/powerpoint/2010/main" val="2670286286"/>
+                <p14:modId xmlns:p14="http://schemas.microsoft.com/office/powerpoint/2010/main" val="3729780605"/>
               </p:ext>
             </p:extLst>
           </p:nvPr>
         </p:nvGraphicFramePr>
         <p:xfrm>
-          <a:off x="1488141" y="2695239"/>
-          <a:ext cx="6159500" cy="2392680"/>
+          <a:off x="968188" y="2048908"/>
+          <a:ext cx="7718612" cy="2712720"/>
         </p:xfrm>
         <a:graphic>
           <a:graphicData uri="http://schemas.openxmlformats.org/drawingml/2006/table">
@@ -3357,7 +3357,7 @@
                 <a:tableStyleId>{5C22544A-7EE6-4342-B048-85BDC9FD1C3A}</a:tableStyleId>
               </a:tblPr>
               <a:tblGrid>
-                <a:gridCol w="6159500">
+                <a:gridCol w="7718612">
                   <a:extLst>
                     <a:ext uri="{9D8B030D-6E8A-4147-A177-3AD203B41FA5}">
                       <a16:colId xmlns:a16="http://schemas.microsoft.com/office/drawing/2014/main" val="1162372424"/>
@@ -3365,26 +3365,24 @@
                   </a:extLst>
                 </a:gridCol>
               </a:tblGrid>
-              <a:tr h="182880">
+              <a:tr h="152641">
                 <a:tc>
                   <a:txBody>
                     <a:bodyPr/>
                     <a:lstStyle/>
                     <a:p>
-                      <a:pPr algn="l" fontAlgn="b"/>
+                      <a:pPr marL="0" algn="l" defTabSz="914400" rtl="0" eaLnBrk="1" fontAlgn="b" latinLnBrk="0" hangingPunct="1"/>
                       <a:r>
-                        <a:rPr lang="en-US" sz="1100" b="1" u="sng" strike="noStrike" dirty="0">
-                          <a:effectLst/>
+                        <a:rPr lang="en-US" sz="1800" b="1" kern="1200" dirty="0">
+                          <a:solidFill>
+                            <a:schemeClr val="tx1"/>
+                          </a:solidFill>
+                          <a:latin typeface="+mn-lt"/>
+                          <a:ea typeface="+mn-ea"/>
+                          <a:cs typeface="+mn-cs"/>
                         </a:rPr>
-                        <a:t>❓Key Business Questions to Explore</a:t>
+                        <a:t>Key Business Questions to Explore</a:t>
                       </a:r>
-                      <a:endParaRPr lang="en-US" sz="1100" b="1" i="0" u="sng" strike="noStrike" dirty="0">
-                        <a:solidFill>
-                          <a:srgbClr val="000000"/>
-                        </a:solidFill>
-                        <a:effectLst/>
-                        <a:latin typeface="Calibri" panose="020F0502020204030204" pitchFamily="34" charset="0"/>
-                      </a:endParaRPr>
                     </a:p>
                   </a:txBody>
                   <a:tcPr marL="7620" marR="7620" marT="7620" marB="0" anchor="b"/>
@@ -3395,50 +3393,24 @@
                   </a:ext>
                 </a:extLst>
               </a:tr>
-              <a:tr h="182880">
+              <a:tr h="152641">
                 <a:tc>
                   <a:txBody>
                     <a:bodyPr/>
                     <a:lstStyle/>
                     <a:p>
-                      <a:pPr algn="l" fontAlgn="b"/>
-                      <a:endParaRPr lang="en-US" sz="1100" b="0" i="0" u="none" strike="noStrike" dirty="0">
-                        <a:solidFill>
-                          <a:srgbClr val="000000"/>
-                        </a:solidFill>
-                        <a:effectLst/>
-                        <a:latin typeface="Calibri" panose="020F0502020204030204" pitchFamily="34" charset="0"/>
-                      </a:endParaRPr>
-                    </a:p>
-                  </a:txBody>
-                  <a:tcPr marL="7620" marR="7620" marT="7620" marB="0" anchor="b"/>
-                </a:tc>
-                <a:extLst>
-                  <a:ext uri="{0D108BD9-81ED-4DB2-BD59-A6C34878D82A}">
-                    <a16:rowId xmlns:a16="http://schemas.microsoft.com/office/drawing/2014/main" val="4174596547"/>
-                  </a:ext>
-                </a:extLst>
-              </a:tr>
-              <a:tr h="182880">
-                <a:tc>
-                  <a:txBody>
-                    <a:bodyPr/>
-                    <a:lstStyle/>
-                    <a:p>
-                      <a:pPr algn="l" fontAlgn="b"/>
+                      <a:pPr marL="0" algn="l" defTabSz="914400" rtl="0" eaLnBrk="1" fontAlgn="b" latinLnBrk="0" hangingPunct="1"/>
                       <a:r>
-                        <a:rPr lang="en-US" sz="1100" u="none" strike="noStrike" dirty="0">
-                          <a:effectLst/>
+                        <a:rPr lang="en-US" sz="1400" kern="1200" dirty="0">
+                          <a:solidFill>
+                            <a:schemeClr val="tx1"/>
+                          </a:solidFill>
+                          <a:latin typeface="+mn-lt"/>
+                          <a:ea typeface="+mn-ea"/>
+                          <a:cs typeface="+mn-cs"/>
                         </a:rPr>
                         <a:t>What’s the overall churn rate?</a:t>
                       </a:r>
-                      <a:endParaRPr lang="en-US" sz="1100" b="0" i="0" u="none" strike="noStrike" dirty="0">
-                        <a:solidFill>
-                          <a:srgbClr val="000000"/>
-                        </a:solidFill>
-                        <a:effectLst/>
-                        <a:latin typeface="Calibri" panose="020F0502020204030204" pitchFamily="34" charset="0"/>
-                      </a:endParaRPr>
                     </a:p>
                   </a:txBody>
                   <a:tcPr marL="7620" marR="7620" marT="7620" marB="0" anchor="b"/>
@@ -3449,26 +3421,24 @@
                   </a:ext>
                 </a:extLst>
               </a:tr>
-              <a:tr h="182880">
+              <a:tr h="152641">
                 <a:tc>
                   <a:txBody>
                     <a:bodyPr/>
                     <a:lstStyle/>
                     <a:p>
-                      <a:pPr algn="l" fontAlgn="b"/>
+                      <a:pPr marL="0" algn="l" defTabSz="914400" rtl="0" eaLnBrk="1" fontAlgn="b" latinLnBrk="0" hangingPunct="1"/>
                       <a:r>
-                        <a:rPr lang="en-US" sz="1100" u="none" strike="noStrike">
-                          <a:effectLst/>
+                        <a:rPr lang="en-US" sz="1400" kern="1200" dirty="0">
+                          <a:solidFill>
+                            <a:schemeClr val="tx1"/>
+                          </a:solidFill>
+                          <a:latin typeface="+mn-lt"/>
+                          <a:ea typeface="+mn-ea"/>
+                          <a:cs typeface="+mn-cs"/>
                         </a:rPr>
                         <a:t>Which age group is churning the most?</a:t>
                       </a:r>
-                      <a:endParaRPr lang="en-US" sz="1100" b="0" i="0" u="none" strike="noStrike">
-                        <a:solidFill>
-                          <a:srgbClr val="000000"/>
-                        </a:solidFill>
-                        <a:effectLst/>
-                        <a:latin typeface="Calibri" panose="020F0502020204030204" pitchFamily="34" charset="0"/>
-                      </a:endParaRPr>
                     </a:p>
                   </a:txBody>
                   <a:tcPr marL="7620" marR="7620" marT="7620" marB="0" anchor="b"/>
@@ -3479,26 +3449,24 @@
                   </a:ext>
                 </a:extLst>
               </a:tr>
-              <a:tr h="182880">
+              <a:tr h="152641">
                 <a:tc>
                   <a:txBody>
                     <a:bodyPr/>
                     <a:lstStyle/>
                     <a:p>
-                      <a:pPr algn="l" fontAlgn="b"/>
+                      <a:pPr marL="0" algn="l" defTabSz="914400" rtl="0" eaLnBrk="1" fontAlgn="b" latinLnBrk="0" hangingPunct="1"/>
                       <a:r>
-                        <a:rPr lang="en-US" sz="1100" u="none" strike="noStrike">
-                          <a:effectLst/>
+                        <a:rPr lang="en-US" sz="1400" kern="1200" dirty="0">
+                          <a:solidFill>
+                            <a:schemeClr val="tx1"/>
+                          </a:solidFill>
+                          <a:latin typeface="+mn-lt"/>
+                          <a:ea typeface="+mn-ea"/>
+                          <a:cs typeface="+mn-cs"/>
                         </a:rPr>
                         <a:t>Do customers with higher credit scores churn less?</a:t>
                       </a:r>
-                      <a:endParaRPr lang="en-US" sz="1100" b="0" i="0" u="none" strike="noStrike">
-                        <a:solidFill>
-                          <a:srgbClr val="000000"/>
-                        </a:solidFill>
-                        <a:effectLst/>
-                        <a:latin typeface="Calibri" panose="020F0502020204030204" pitchFamily="34" charset="0"/>
-                      </a:endParaRPr>
                     </a:p>
                   </a:txBody>
                   <a:tcPr marL="7620" marR="7620" marT="7620" marB="0" anchor="b"/>
@@ -3509,26 +3477,24 @@
                   </a:ext>
                 </a:extLst>
               </a:tr>
-              <a:tr h="182880">
+              <a:tr h="152641">
                 <a:tc>
                   <a:txBody>
                     <a:bodyPr/>
                     <a:lstStyle/>
                     <a:p>
-                      <a:pPr algn="l" fontAlgn="b"/>
+                      <a:pPr marL="0" algn="l" defTabSz="914400" rtl="0" eaLnBrk="1" fontAlgn="b" latinLnBrk="0" hangingPunct="1"/>
                       <a:r>
-                        <a:rPr lang="en-US" sz="1100" u="none" strike="noStrike">
-                          <a:effectLst/>
+                        <a:rPr lang="en-US" sz="1400" kern="1200" dirty="0">
+                          <a:solidFill>
+                            <a:schemeClr val="tx1"/>
+                          </a:solidFill>
+                          <a:latin typeface="+mn-lt"/>
+                          <a:ea typeface="+mn-ea"/>
+                          <a:cs typeface="+mn-cs"/>
                         </a:rPr>
                         <a:t>Does geography (France, Germany, Spain) affect churn?</a:t>
                       </a:r>
-                      <a:endParaRPr lang="en-US" sz="1100" b="0" i="0" u="none" strike="noStrike">
-                        <a:solidFill>
-                          <a:srgbClr val="000000"/>
-                        </a:solidFill>
-                        <a:effectLst/>
-                        <a:latin typeface="Calibri" panose="020F0502020204030204" pitchFamily="34" charset="0"/>
-                      </a:endParaRPr>
                     </a:p>
                   </a:txBody>
                   <a:tcPr marL="7620" marR="7620" marT="7620" marB="0" anchor="b"/>
@@ -3539,26 +3505,24 @@
                   </a:ext>
                 </a:extLst>
               </a:tr>
-              <a:tr h="198120">
+              <a:tr h="152641">
                 <a:tc>
                   <a:txBody>
                     <a:bodyPr/>
                     <a:lstStyle/>
                     <a:p>
-                      <a:pPr algn="l" fontAlgn="b"/>
+                      <a:pPr marL="0" algn="l" defTabSz="914400" rtl="0" eaLnBrk="1" fontAlgn="b" latinLnBrk="0" hangingPunct="1"/>
                       <a:r>
-                        <a:rPr lang="en-US" sz="1100" u="none" strike="noStrike">
-                          <a:effectLst/>
+                        <a:rPr lang="en-US" sz="1400" kern="1200" dirty="0">
+                          <a:solidFill>
+                            <a:schemeClr val="tx1"/>
+                          </a:solidFill>
+                          <a:latin typeface="+mn-lt"/>
+                          <a:ea typeface="+mn-ea"/>
+                          <a:cs typeface="+mn-cs"/>
                         </a:rPr>
                         <a:t>Are active members less likely to churn?</a:t>
                       </a:r>
-                      <a:endParaRPr lang="en-US" sz="1100" b="0" i="0" u="none" strike="noStrike">
-                        <a:solidFill>
-                          <a:srgbClr val="000000"/>
-                        </a:solidFill>
-                        <a:effectLst/>
-                        <a:latin typeface="Calibri" panose="020F0502020204030204" pitchFamily="34" charset="0"/>
-                      </a:endParaRPr>
                     </a:p>
                   </a:txBody>
                   <a:tcPr marL="7620" marR="7620" marT="7620" marB="0" anchor="b"/>
@@ -3569,26 +3533,24 @@
                   </a:ext>
                 </a:extLst>
               </a:tr>
-              <a:tr h="182880">
+              <a:tr h="152641">
                 <a:tc>
                   <a:txBody>
                     <a:bodyPr/>
                     <a:lstStyle/>
                     <a:p>
-                      <a:pPr algn="l" fontAlgn="b"/>
+                      <a:pPr marL="0" algn="l" defTabSz="914400" rtl="0" eaLnBrk="1" fontAlgn="b" latinLnBrk="0" hangingPunct="1"/>
                       <a:r>
-                        <a:rPr lang="en-US" sz="1100" u="none" strike="noStrike">
-                          <a:effectLst/>
+                        <a:rPr lang="en-US" sz="1400" kern="1200" dirty="0">
+                          <a:solidFill>
+                            <a:schemeClr val="tx1"/>
+                          </a:solidFill>
+                          <a:latin typeface="+mn-lt"/>
+                          <a:ea typeface="+mn-ea"/>
+                          <a:cs typeface="+mn-cs"/>
                         </a:rPr>
                         <a:t>How does gender affect churn?</a:t>
                       </a:r>
-                      <a:endParaRPr lang="en-US" sz="1100" b="0" i="0" u="none" strike="noStrike">
-                        <a:solidFill>
-                          <a:srgbClr val="000000"/>
-                        </a:solidFill>
-                        <a:effectLst/>
-                        <a:latin typeface="Calibri" panose="020F0502020204030204" pitchFamily="34" charset="0"/>
-                      </a:endParaRPr>
                     </a:p>
                   </a:txBody>
                   <a:tcPr marL="7620" marR="7620" marT="7620" marB="0" anchor="b"/>
@@ -3599,26 +3561,24 @@
                   </a:ext>
                 </a:extLst>
               </a:tr>
-              <a:tr h="182880">
+              <a:tr h="152641">
                 <a:tc>
                   <a:txBody>
                     <a:bodyPr/>
                     <a:lstStyle/>
                     <a:p>
-                      <a:pPr algn="l" fontAlgn="b"/>
+                      <a:pPr marL="0" algn="l" defTabSz="914400" rtl="0" eaLnBrk="1" fontAlgn="b" latinLnBrk="0" hangingPunct="1"/>
                       <a:r>
-                        <a:rPr lang="en-US" sz="1100" u="none" strike="noStrike">
-                          <a:effectLst/>
+                        <a:rPr lang="en-US" sz="1400" kern="1200" dirty="0">
+                          <a:solidFill>
+                            <a:schemeClr val="tx1"/>
+                          </a:solidFill>
+                          <a:latin typeface="+mn-lt"/>
+                          <a:ea typeface="+mn-ea"/>
+                          <a:cs typeface="+mn-cs"/>
                         </a:rPr>
                         <a:t>What’s the relationship between account balance and churn?</a:t>
                       </a:r>
-                      <a:endParaRPr lang="en-US" sz="1100" b="0" i="0" u="none" strike="noStrike">
-                        <a:solidFill>
-                          <a:srgbClr val="000000"/>
-                        </a:solidFill>
-                        <a:effectLst/>
-                        <a:latin typeface="Calibri" panose="020F0502020204030204" pitchFamily="34" charset="0"/>
-                      </a:endParaRPr>
                     </a:p>
                   </a:txBody>
                   <a:tcPr marL="7620" marR="7620" marT="7620" marB="0" anchor="b"/>
@@ -3629,26 +3589,24 @@
                   </a:ext>
                 </a:extLst>
               </a:tr>
-              <a:tr h="182880">
+              <a:tr h="152641">
                 <a:tc>
                   <a:txBody>
                     <a:bodyPr/>
                     <a:lstStyle/>
                     <a:p>
-                      <a:pPr algn="l" fontAlgn="b"/>
+                      <a:pPr marL="0" algn="l" defTabSz="914400" rtl="0" eaLnBrk="1" fontAlgn="b" latinLnBrk="0" hangingPunct="1"/>
                       <a:r>
-                        <a:rPr lang="en-US" sz="1100" u="none" strike="noStrike">
-                          <a:effectLst/>
+                        <a:rPr lang="en-US" sz="1400" kern="1200">
+                          <a:solidFill>
+                            <a:schemeClr val="tx1"/>
+                          </a:solidFill>
+                          <a:latin typeface="+mn-lt"/>
+                          <a:ea typeface="+mn-ea"/>
+                          <a:cs typeface="+mn-cs"/>
                         </a:rPr>
                         <a:t>Is there a pattern in churn based on number of products owned?</a:t>
                       </a:r>
-                      <a:endParaRPr lang="en-US" sz="1100" b="0" i="0" u="none" strike="noStrike">
-                        <a:solidFill>
-                          <a:srgbClr val="000000"/>
-                        </a:solidFill>
-                        <a:effectLst/>
-                        <a:latin typeface="Calibri" panose="020F0502020204030204" pitchFamily="34" charset="0"/>
-                      </a:endParaRPr>
                     </a:p>
                   </a:txBody>
                   <a:tcPr marL="7620" marR="7620" marT="7620" marB="0" anchor="b"/>
@@ -3659,26 +3617,24 @@
                   </a:ext>
                 </a:extLst>
               </a:tr>
-              <a:tr h="182880">
+              <a:tr h="152641">
                 <a:tc>
                   <a:txBody>
                     <a:bodyPr/>
                     <a:lstStyle/>
                     <a:p>
-                      <a:pPr algn="l" fontAlgn="b"/>
+                      <a:pPr marL="0" algn="l" defTabSz="914400" rtl="0" eaLnBrk="1" fontAlgn="b" latinLnBrk="0" hangingPunct="1"/>
                       <a:r>
-                        <a:rPr lang="en-US" sz="1100" u="none" strike="noStrike">
-                          <a:effectLst/>
+                        <a:rPr lang="en-US" sz="1400" kern="1200" dirty="0">
+                          <a:solidFill>
+                            <a:schemeClr val="tx1"/>
+                          </a:solidFill>
+                          <a:latin typeface="+mn-lt"/>
+                          <a:ea typeface="+mn-ea"/>
+                          <a:cs typeface="+mn-cs"/>
                         </a:rPr>
                         <a:t>Do higher salaried customers stay longer?</a:t>
                       </a:r>
-                      <a:endParaRPr lang="en-US" sz="1100" b="0" i="0" u="none" strike="noStrike">
-                        <a:solidFill>
-                          <a:srgbClr val="000000"/>
-                        </a:solidFill>
-                        <a:effectLst/>
-                        <a:latin typeface="Calibri" panose="020F0502020204030204" pitchFamily="34" charset="0"/>
-                      </a:endParaRPr>
                     </a:p>
                   </a:txBody>
                   <a:tcPr marL="7620" marR="7620" marT="7620" marB="0" anchor="b"/>
@@ -3689,26 +3645,24 @@
                   </a:ext>
                 </a:extLst>
               </a:tr>
-              <a:tr h="182880">
+              <a:tr h="152641">
                 <a:tc>
                   <a:txBody>
                     <a:bodyPr/>
                     <a:lstStyle/>
                     <a:p>
-                      <a:pPr algn="l" fontAlgn="b"/>
+                      <a:pPr marL="0" algn="l" defTabSz="914400" rtl="0" eaLnBrk="1" fontAlgn="b" latinLnBrk="0" hangingPunct="1"/>
                       <a:r>
-                        <a:rPr lang="en-US" sz="1100" u="none" strike="noStrike">
-                          <a:effectLst/>
+                        <a:rPr lang="en-US" sz="1400" kern="1200">
+                          <a:solidFill>
+                            <a:schemeClr val="tx1"/>
+                          </a:solidFill>
+                          <a:latin typeface="+mn-lt"/>
+                          <a:ea typeface="+mn-ea"/>
+                          <a:cs typeface="+mn-cs"/>
                         </a:rPr>
                         <a:t>Does having a credit card influence churn?</a:t>
                       </a:r>
-                      <a:endParaRPr lang="en-US" sz="1100" b="0" i="0" u="none" strike="noStrike">
-                        <a:solidFill>
-                          <a:srgbClr val="000000"/>
-                        </a:solidFill>
-                        <a:effectLst/>
-                        <a:latin typeface="Calibri" panose="020F0502020204030204" pitchFamily="34" charset="0"/>
-                      </a:endParaRPr>
                     </a:p>
                   </a:txBody>
                   <a:tcPr marL="7620" marR="7620" marT="7620" marB="0" anchor="b"/>
@@ -3719,38 +3673,24 @@
                   </a:ext>
                 </a:extLst>
               </a:tr>
-              <a:tr h="182880">
+              <a:tr h="152641">
                 <a:tc>
                   <a:txBody>
                     <a:bodyPr/>
                     <a:lstStyle/>
                     <a:p>
-                      <a:pPr algn="l" fontAlgn="b"/>
+                      <a:pPr marL="0" algn="l" defTabSz="914400" rtl="0" eaLnBrk="1" fontAlgn="b" latinLnBrk="0" hangingPunct="1"/>
                       <a:r>
-                        <a:rPr lang="en-US" sz="1100" u="none" strike="noStrike" dirty="0">
-                          <a:effectLst/>
+                        <a:rPr lang="en-US" sz="1400" kern="1200" dirty="0">
+                          <a:solidFill>
+                            <a:schemeClr val="tx1"/>
+                          </a:solidFill>
+                          <a:latin typeface="+mn-lt"/>
+                          <a:ea typeface="+mn-ea"/>
+                          <a:cs typeface="+mn-cs"/>
                         </a:rPr>
-                        <a:t>Is </a:t>
+                        <a:t>Is there a relationship between age and churn </a:t>
                       </a:r>
-                      <a:r>
-                        <a:rPr lang="en-US" sz="1100" u="none" strike="noStrike" dirty="0" err="1">
-                          <a:effectLst/>
-                        </a:rPr>
-                        <a:t>Tthere</a:t>
-                      </a:r>
-                      <a:r>
-                        <a:rPr lang="en-US" sz="1100" u="none" strike="noStrike" dirty="0">
-                          <a:effectLst/>
-                        </a:rPr>
-                        <a:t> a relationship between age and churn </a:t>
-                      </a:r>
-                      <a:endParaRPr lang="en-US" sz="1100" b="0" i="0" u="none" strike="noStrike" dirty="0">
-                        <a:solidFill>
-                          <a:srgbClr val="000000"/>
-                        </a:solidFill>
-                        <a:effectLst/>
-                        <a:latin typeface="Calibri" panose="020F0502020204030204" pitchFamily="34" charset="0"/>
-                      </a:endParaRPr>
                     </a:p>
                   </a:txBody>
                   <a:tcPr marL="7620" marR="7620" marT="7620" marB="0" anchor="b"/>
@@ -3849,6 +3789,374 @@
           </a:p>
         </p:txBody>
       </p:sp>
+      <p:graphicFrame>
+        <p:nvGraphicFramePr>
+          <p:cNvPr id="2" name="Table 1">
+            <a:extLst>
+              <a:ext uri="{FF2B5EF4-FFF2-40B4-BE49-F238E27FC236}">
+                <a16:creationId xmlns:a16="http://schemas.microsoft.com/office/drawing/2014/main" id="{6E8E60C4-ADCC-547A-A033-2FDBB53747FF}"/>
+              </a:ext>
+            </a:extLst>
+          </p:cNvPr>
+          <p:cNvGraphicFramePr>
+            <a:graphicFrameLocks noGrp="1"/>
+          </p:cNvGraphicFramePr>
+          <p:nvPr>
+            <p:extLst>
+              <p:ext uri="{D42A27DB-BD31-4B8C-83A1-F6EECF244321}">
+                <p14:modId xmlns:p14="http://schemas.microsoft.com/office/powerpoint/2010/main" val="2921549532"/>
+              </p:ext>
+            </p:extLst>
+          </p:nvPr>
+        </p:nvGraphicFramePr>
+        <p:xfrm>
+          <a:off x="806823" y="5260268"/>
+          <a:ext cx="8888506" cy="1346720"/>
+        </p:xfrm>
+        <a:graphic>
+          <a:graphicData uri="http://schemas.openxmlformats.org/drawingml/2006/table">
+            <a:tbl>
+              <a:tblPr>
+                <a:tableStyleId>{5C22544A-7EE6-4342-B048-85BDC9FD1C3A}</a:tableStyleId>
+              </a:tblPr>
+              <a:tblGrid>
+                <a:gridCol w="4645394">
+                  <a:extLst>
+                    <a:ext uri="{9D8B030D-6E8A-4147-A177-3AD203B41FA5}">
+                      <a16:colId xmlns:a16="http://schemas.microsoft.com/office/drawing/2014/main" val="2976365971"/>
+                    </a:ext>
+                  </a:extLst>
+                </a:gridCol>
+                <a:gridCol w="4243112">
+                  <a:extLst>
+                    <a:ext uri="{9D8B030D-6E8A-4147-A177-3AD203B41FA5}">
+                      <a16:colId xmlns:a16="http://schemas.microsoft.com/office/drawing/2014/main" val="2019941063"/>
+                    </a:ext>
+                  </a:extLst>
+                </a:gridCol>
+              </a:tblGrid>
+              <a:tr h="108218">
+                <a:tc>
+                  <a:txBody>
+                    <a:bodyPr/>
+                    <a:lstStyle/>
+                    <a:p>
+                      <a:pPr algn="l" fontAlgn="b"/>
+                      <a:r>
+                        <a:rPr lang="en-US" sz="1200" u="none" strike="noStrike">
+                          <a:effectLst/>
+                        </a:rPr>
+                        <a:t>Segment Type</a:t>
+                      </a:r>
+                      <a:endParaRPr lang="en-US" sz="1200" b="0" i="0" u="none" strike="noStrike">
+                        <a:solidFill>
+                          <a:srgbClr val="000000"/>
+                        </a:solidFill>
+                        <a:effectLst/>
+                        <a:latin typeface="Calibri" panose="020F0502020204030204" pitchFamily="34" charset="0"/>
+                      </a:endParaRPr>
+                    </a:p>
+                  </a:txBody>
+                  <a:tcPr marL="6799" marR="6799" marT="6799" marB="0" anchor="b"/>
+                </a:tc>
+                <a:tc>
+                  <a:txBody>
+                    <a:bodyPr/>
+                    <a:lstStyle/>
+                    <a:p>
+                      <a:pPr algn="l" fontAlgn="b"/>
+                      <a:r>
+                        <a:rPr lang="en-US" sz="1200" u="none" strike="noStrike">
+                          <a:effectLst/>
+                        </a:rPr>
+                        <a:t>Example Characteristics</a:t>
+                      </a:r>
+                      <a:endParaRPr lang="en-US" sz="1200" b="0" i="0" u="none" strike="noStrike">
+                        <a:solidFill>
+                          <a:srgbClr val="000000"/>
+                        </a:solidFill>
+                        <a:effectLst/>
+                        <a:latin typeface="Calibri" panose="020F0502020204030204" pitchFamily="34" charset="0"/>
+                      </a:endParaRPr>
+                    </a:p>
+                  </a:txBody>
+                  <a:tcPr marL="6799" marR="6799" marT="6799" marB="0" anchor="b"/>
+                </a:tc>
+                <a:extLst>
+                  <a:ext uri="{0D108BD9-81ED-4DB2-BD59-A6C34878D82A}">
+                    <a16:rowId xmlns:a16="http://schemas.microsoft.com/office/drawing/2014/main" val="3782373070"/>
+                  </a:ext>
+                </a:extLst>
+              </a:tr>
+              <a:tr h="108218">
+                <a:tc>
+                  <a:txBody>
+                    <a:bodyPr/>
+                    <a:lstStyle/>
+                    <a:p>
+                      <a:pPr algn="l" fontAlgn="b"/>
+                      <a:r>
+                        <a:rPr lang="en-US" sz="1200" u="none" strike="noStrike">
+                          <a:effectLst/>
+                        </a:rPr>
+                        <a:t>High-Value Loyal</a:t>
+                      </a:r>
+                      <a:endParaRPr lang="en-US" sz="1200" b="0" i="0" u="none" strike="noStrike">
+                        <a:solidFill>
+                          <a:srgbClr val="000000"/>
+                        </a:solidFill>
+                        <a:effectLst/>
+                        <a:latin typeface="Calibri" panose="020F0502020204030204" pitchFamily="34" charset="0"/>
+                      </a:endParaRPr>
+                    </a:p>
+                  </a:txBody>
+                  <a:tcPr marL="6799" marR="6799" marT="6799" marB="0" anchor="b"/>
+                </a:tc>
+                <a:tc>
+                  <a:txBody>
+                    <a:bodyPr/>
+                    <a:lstStyle/>
+                    <a:p>
+                      <a:pPr algn="l" fontAlgn="b"/>
+                      <a:r>
+                        <a:rPr lang="en-US" sz="1200" u="none" strike="noStrike">
+                          <a:effectLst/>
+                        </a:rPr>
+                        <a:t>High balance, active, many products, low churn risk</a:t>
+                      </a:r>
+                      <a:endParaRPr lang="en-US" sz="1200" b="0" i="0" u="none" strike="noStrike">
+                        <a:solidFill>
+                          <a:srgbClr val="000000"/>
+                        </a:solidFill>
+                        <a:effectLst/>
+                        <a:latin typeface="Calibri" panose="020F0502020204030204" pitchFamily="34" charset="0"/>
+                      </a:endParaRPr>
+                    </a:p>
+                  </a:txBody>
+                  <a:tcPr marL="6799" marR="6799" marT="6799" marB="0" anchor="b"/>
+                </a:tc>
+                <a:extLst>
+                  <a:ext uri="{0D108BD9-81ED-4DB2-BD59-A6C34878D82A}">
+                    <a16:rowId xmlns:a16="http://schemas.microsoft.com/office/drawing/2014/main" val="1774935414"/>
+                  </a:ext>
+                </a:extLst>
+              </a:tr>
+              <a:tr h="202562">
+                <a:tc>
+                  <a:txBody>
+                    <a:bodyPr/>
+                    <a:lstStyle/>
+                    <a:p>
+                      <a:pPr algn="l" fontAlgn="b"/>
+                      <a:r>
+                        <a:rPr lang="en-US" sz="1200" u="none" strike="noStrike" dirty="0">
+                          <a:effectLst/>
+                        </a:rPr>
+                        <a:t>At-Risk Churners</a:t>
+                      </a:r>
+                      <a:endParaRPr lang="en-US" sz="1200" b="0" i="0" u="none" strike="noStrike" dirty="0">
+                        <a:solidFill>
+                          <a:srgbClr val="000000"/>
+                        </a:solidFill>
+                        <a:effectLst/>
+                        <a:latin typeface="Calibri" panose="020F0502020204030204" pitchFamily="34" charset="0"/>
+                      </a:endParaRPr>
+                    </a:p>
+                  </a:txBody>
+                  <a:tcPr marL="6799" marR="6799" marT="6799" marB="0" anchor="b"/>
+                </a:tc>
+                <a:tc>
+                  <a:txBody>
+                    <a:bodyPr/>
+                    <a:lstStyle/>
+                    <a:p>
+                      <a:pPr algn="l" fontAlgn="b"/>
+                      <a:r>
+                        <a:rPr lang="en-US" sz="1200" u="none" strike="noStrike">
+                          <a:effectLst/>
+                        </a:rPr>
+                        <a:t>Inactive, older, high balance, from Germany, churned or likely to churn</a:t>
+                      </a:r>
+                      <a:endParaRPr lang="en-US" sz="1200" b="0" i="0" u="none" strike="noStrike">
+                        <a:solidFill>
+                          <a:srgbClr val="000000"/>
+                        </a:solidFill>
+                        <a:effectLst/>
+                        <a:latin typeface="Calibri" panose="020F0502020204030204" pitchFamily="34" charset="0"/>
+                      </a:endParaRPr>
+                    </a:p>
+                  </a:txBody>
+                  <a:tcPr marL="6799" marR="6799" marT="6799" marB="0" anchor="b"/>
+                </a:tc>
+                <a:extLst>
+                  <a:ext uri="{0D108BD9-81ED-4DB2-BD59-A6C34878D82A}">
+                    <a16:rowId xmlns:a16="http://schemas.microsoft.com/office/drawing/2014/main" val="3939386265"/>
+                  </a:ext>
+                </a:extLst>
+              </a:tr>
+              <a:tr h="202562">
+                <a:tc>
+                  <a:txBody>
+                    <a:bodyPr/>
+                    <a:lstStyle/>
+                    <a:p>
+                      <a:pPr algn="l" fontAlgn="b"/>
+                      <a:r>
+                        <a:rPr lang="en-US" sz="1200" u="none" strike="noStrike">
+                          <a:effectLst/>
+                        </a:rPr>
+                        <a:t>Young and Low Engagement</a:t>
+                      </a:r>
+                      <a:endParaRPr lang="en-US" sz="1200" b="0" i="0" u="none" strike="noStrike">
+                        <a:solidFill>
+                          <a:srgbClr val="000000"/>
+                        </a:solidFill>
+                        <a:effectLst/>
+                        <a:latin typeface="Calibri" panose="020F0502020204030204" pitchFamily="34" charset="0"/>
+                      </a:endParaRPr>
+                    </a:p>
+                  </a:txBody>
+                  <a:tcPr marL="6799" marR="6799" marT="6799" marB="0" anchor="b"/>
+                </a:tc>
+                <a:tc>
+                  <a:txBody>
+                    <a:bodyPr/>
+                    <a:lstStyle/>
+                    <a:p>
+                      <a:pPr algn="l" fontAlgn="b"/>
+                      <a:r>
+                        <a:rPr lang="en-US" sz="1200" u="none" strike="noStrike">
+                          <a:effectLst/>
+                        </a:rPr>
+                        <a:t>Young, low balance, only 1 product, low salary, not very active</a:t>
+                      </a:r>
+                      <a:endParaRPr lang="en-US" sz="1200" b="0" i="0" u="none" strike="noStrike">
+                        <a:solidFill>
+                          <a:srgbClr val="000000"/>
+                        </a:solidFill>
+                        <a:effectLst/>
+                        <a:latin typeface="Calibri" panose="020F0502020204030204" pitchFamily="34" charset="0"/>
+                      </a:endParaRPr>
+                    </a:p>
+                  </a:txBody>
+                  <a:tcPr marL="6799" marR="6799" marT="6799" marB="0" anchor="b"/>
+                </a:tc>
+                <a:extLst>
+                  <a:ext uri="{0D108BD9-81ED-4DB2-BD59-A6C34878D82A}">
+                    <a16:rowId xmlns:a16="http://schemas.microsoft.com/office/drawing/2014/main" val="3575232791"/>
+                  </a:ext>
+                </a:extLst>
+              </a:tr>
+              <a:tr h="202562">
+                <a:tc>
+                  <a:txBody>
+                    <a:bodyPr/>
+                    <a:lstStyle/>
+                    <a:p>
+                      <a:pPr algn="l" fontAlgn="b"/>
+                      <a:r>
+                        <a:rPr lang="en-US" sz="1200" u="none" strike="noStrike">
+                          <a:effectLst/>
+                        </a:rPr>
+                        <a:t>Credit-Conscious Customers</a:t>
+                      </a:r>
+                      <a:endParaRPr lang="en-US" sz="1200" b="0" i="0" u="none" strike="noStrike">
+                        <a:solidFill>
+                          <a:srgbClr val="000000"/>
+                        </a:solidFill>
+                        <a:effectLst/>
+                        <a:latin typeface="Calibri" panose="020F0502020204030204" pitchFamily="34" charset="0"/>
+                      </a:endParaRPr>
+                    </a:p>
+                  </a:txBody>
+                  <a:tcPr marL="6799" marR="6799" marT="6799" marB="0" anchor="b"/>
+                </a:tc>
+                <a:tc>
+                  <a:txBody>
+                    <a:bodyPr/>
+                    <a:lstStyle/>
+                    <a:p>
+                      <a:pPr algn="l" fontAlgn="b"/>
+                      <a:r>
+                        <a:rPr lang="en-US" sz="1200" u="none" strike="noStrike">
+                          <a:effectLst/>
+                        </a:rPr>
+                        <a:t>High credit score, moderate balance, cautious product usage</a:t>
+                      </a:r>
+                      <a:endParaRPr lang="en-US" sz="1200" b="0" i="0" u="none" strike="noStrike">
+                        <a:solidFill>
+                          <a:srgbClr val="000000"/>
+                        </a:solidFill>
+                        <a:effectLst/>
+                        <a:latin typeface="Calibri" panose="020F0502020204030204" pitchFamily="34" charset="0"/>
+                      </a:endParaRPr>
+                    </a:p>
+                  </a:txBody>
+                  <a:tcPr marL="6799" marR="6799" marT="6799" marB="0" anchor="b"/>
+                </a:tc>
+                <a:extLst>
+                  <a:ext uri="{0D108BD9-81ED-4DB2-BD59-A6C34878D82A}">
+                    <a16:rowId xmlns:a16="http://schemas.microsoft.com/office/drawing/2014/main" val="2594683155"/>
+                  </a:ext>
+                </a:extLst>
+              </a:tr>
+              <a:tr h="108218">
+                <a:tc>
+                  <a:txBody>
+                    <a:bodyPr/>
+                    <a:lstStyle/>
+                    <a:p>
+                      <a:pPr algn="l" fontAlgn="ctr"/>
+                      <a:r>
+                        <a:rPr lang="en-US" sz="1200" u="none" strike="noStrike">
+                          <a:effectLst/>
+                        </a:rPr>
+                        <a:t>Salary-Driven Users</a:t>
+                      </a:r>
+                      <a:endParaRPr lang="en-US" sz="1200" b="1" i="0" u="none" strike="noStrike">
+                        <a:solidFill>
+                          <a:srgbClr val="000000"/>
+                        </a:solidFill>
+                        <a:effectLst/>
+                        <a:latin typeface="Calibri" panose="020F0502020204030204" pitchFamily="34" charset="0"/>
+                      </a:endParaRPr>
+                    </a:p>
+                  </a:txBody>
+                  <a:tcPr marL="6799" marR="6799" marT="6799" marB="0" anchor="ctr"/>
+                </a:tc>
+                <a:tc>
+                  <a:txBody>
+                    <a:bodyPr/>
+                    <a:lstStyle/>
+                    <a:p>
+                      <a:pPr algn="l" fontAlgn="ctr"/>
+                      <a:r>
+                        <a:rPr lang="en-US" sz="1200" u="none" strike="noStrike" dirty="0">
+                          <a:effectLst/>
+                        </a:rPr>
+                        <a:t>High salary, but low balance and few products</a:t>
+                      </a:r>
+                      <a:endParaRPr lang="en-US" sz="1200" b="0" i="0" u="none" strike="noStrike" dirty="0">
+                        <a:solidFill>
+                          <a:srgbClr val="000000"/>
+                        </a:solidFill>
+                        <a:effectLst/>
+                        <a:latin typeface="Calibri" panose="020F0502020204030204" pitchFamily="34" charset="0"/>
+                      </a:endParaRPr>
+                    </a:p>
+                  </a:txBody>
+                  <a:tcPr marL="6799" marR="6799" marT="6799" marB="0" anchor="ctr"/>
+                </a:tc>
+                <a:extLst>
+                  <a:ext uri="{0D108BD9-81ED-4DB2-BD59-A6C34878D82A}">
+                    <a16:rowId xmlns:a16="http://schemas.microsoft.com/office/drawing/2014/main" val="549841904"/>
+                  </a:ext>
+                </a:extLst>
+              </a:tr>
+            </a:tbl>
+          </a:graphicData>
+        </a:graphic>
+      </p:graphicFrame>
     </p:spTree>
     <p:extLst>
       <p:ext uri="{BB962C8B-B14F-4D97-AF65-F5344CB8AC3E}">

</xml_diff>